<commit_message>
nasa-jsc-eg: the template's yellow in the dark chart palette
The EG yellow (#FCDB00) takes the HDS orange's place on dark slides:
the third series and the second of every small set. The orange moves to
the tenth slot, in place of HDS's own yellow, so the palette holds one
yellow. Light slides keep HDS's palette (the yellow is 1.4:1 on white).
livery check: the same warnings as nasa-dark.

Co-Authored-By: Claude Opus 5.5 <noreply@anthropic.com>
Claude-Session: https://claude.ai/code/session_016ELREyRJPbKMgLhTztacRH
</commit_message>
<xml_diff>
--- a/liveries/nasa-jsc-eg/template.pptx
+++ b/liveries/nasa-jsc-eg/template.pptx
@@ -3282,8 +3282,8 @@
     <a:custClr name="Data 2 · Red">
       <a:srgbClr val="EF483F"/>
     </a:custClr>
-    <a:custClr name="Data 3 · Orange">
-      <a:srgbClr val="F29D49"/>
+    <a:custClr name="Data 3 · Yellow">
+      <a:srgbClr val="FCDB00"/>
     </a:custClr>
     <a:custClr name="Data 4 · Slate">
       <a:srgbClr val="487682"/>

</xml_diff>

<commit_message>
pptx: closings and dividers honor column.anchor: top
The pptx centered a closing's and a divider's text on the column
whatever its anchor: the Closing layout split the column at its middle,
and section_subtitle.py centered the measured block. With anchor: top:
- a divider's block starts at the column's top;
- the Closing layout top-anchors its headline, and slide_layout's
  closing_top() sets the headline at its measured height and the body
  right under it (0.4 em, the HTML h2's margin), as HTML and PDF flow
  them. Every frame is set whole (a placeholder inherits its frame).

Only a top-anchored closing's template changes (nasa-jsc-eg's).

Co-Authored-By: Claude Opus 5.5 <noreply@anthropic.com>
Claude-Session: https://claude.ai/code/session_016ELREyRJPbKMgLhTztacRH
</commit_message>
<xml_diff>
--- a/liveries/nasa-jsc-eg/template.pptx
+++ b/liveries/nasa-jsc-eg/template.pptx
@@ -421,7 +421,7 @@
           </a:prstGeom>
         </p:spPr>
         <p:txBody>
-          <a:bodyPr vert="horz" lIns="0" tIns="0" rIns="0" bIns="0" anchor="b">
+          <a:bodyPr vert="horz" lIns="0" tIns="0" rIns="0" bIns="0" anchor="t">
             <a:normAutofit/>
           </a:bodyPr>
           <a:lstStyle>
@@ -2133,7 +2133,7 @@
           </a:prstGeom>
         </p:spPr>
         <p:txBody>
-          <a:bodyPr vert="horz" lIns="0" tIns="0" rIns="0" bIns="0" anchor="b">
+          <a:bodyPr vert="horz" lIns="0" tIns="0" rIns="0" bIns="0" anchor="t">
             <a:normAutofit/>
           </a:bodyPr>
           <a:lstStyle>

</xml_diff>